<commit_message>
Regenerate v2 sample outputs from template examples.
Web, document PDF, and deck samples now built from v2 templates; add regenerate_samples.sh script.

Co-authored-by: Cursor <cursoragent@cursor.com>
</commit_message>
<xml_diff>
--- a/intelligaia-design/samples/Intelligaia-deck-sample.pptx
+++ b/intelligaia-design/samples/Intelligaia-deck-sample.pptx
@@ -965,7 +965,7 @@
     <p:bg>
       <p:bgPr>
         <a:solidFill>
-          <a:srgbClr val="0D0D0A"/>
+          <a:srgbClr val="FAFAF6"/>
         </a:solidFill>
       </p:bgPr>
     </p:bg>
@@ -983,105 +983,9 @@
           <a:chExt cx="0" cy="0"/>
         </a:xfrm>
       </p:grpSpPr>
-      <p:sp>
-        <p:nvSpPr>
-          <p:cNvPr id="2" name="Shape 0"/>
-          <p:cNvSpPr/>
-          <p:nvPr/>
-        </p:nvSpPr>
-        <p:spPr>
-          <a:xfrm rot="5400000">
-            <a:off x="10424160" y="365760"/>
-            <a:ext cx="1280160" cy="1152144"/>
-          </a:xfrm>
-          <a:prstGeom prst="hexagon">
-            <a:avLst/>
-          </a:prstGeom>
-          <a:ln w="12700">
-            <a:solidFill>
-              <a:srgbClr val="FFD923">
-                <a:alpha val="18000"/>
-              </a:srgbClr>
-            </a:solidFill>
-            <a:prstDash val="solid"/>
-          </a:ln>
-        </p:spPr>
-      </p:sp>
-      <p:sp>
-        <p:nvSpPr>
-          <p:cNvPr id="3" name="Shape 1"/>
-          <p:cNvSpPr/>
-          <p:nvPr/>
-        </p:nvSpPr>
-        <p:spPr>
-          <a:xfrm rot="5400000">
-            <a:off x="11155680" y="1143000"/>
-            <a:ext cx="1280160" cy="1152144"/>
-          </a:xfrm>
-          <a:prstGeom prst="hexagon">
-            <a:avLst/>
-          </a:prstGeom>
-          <a:ln w="12700">
-            <a:solidFill>
-              <a:srgbClr val="FFD923">
-                <a:alpha val="18000"/>
-              </a:srgbClr>
-            </a:solidFill>
-            <a:prstDash val="solid"/>
-          </a:ln>
-        </p:spPr>
-      </p:sp>
-      <p:sp>
-        <p:nvSpPr>
-          <p:cNvPr id="4" name="Shape 2"/>
-          <p:cNvSpPr/>
-          <p:nvPr/>
-        </p:nvSpPr>
-        <p:spPr>
-          <a:xfrm rot="5400000">
-            <a:off x="9692640" y="1143000"/>
-            <a:ext cx="1280160" cy="1152144"/>
-          </a:xfrm>
-          <a:prstGeom prst="hexagon">
-            <a:avLst/>
-          </a:prstGeom>
-          <a:ln w="12700">
-            <a:solidFill>
-              <a:srgbClr val="FFD923">
-                <a:alpha val="18000"/>
-              </a:srgbClr>
-            </a:solidFill>
-            <a:prstDash val="solid"/>
-          </a:ln>
-        </p:spPr>
-      </p:sp>
-      <p:sp>
-        <p:nvSpPr>
-          <p:cNvPr id="5" name="Shape 3"/>
-          <p:cNvSpPr/>
-          <p:nvPr/>
-        </p:nvSpPr>
-        <p:spPr>
-          <a:xfrm rot="5400000">
-            <a:off x="10424160" y="1920240"/>
-            <a:ext cx="1280160" cy="1152144"/>
-          </a:xfrm>
-          <a:prstGeom prst="hexagon">
-            <a:avLst/>
-          </a:prstGeom>
-          <a:ln w="12700">
-            <a:solidFill>
-              <a:srgbClr val="FFD923">
-                <a:alpha val="18000"/>
-              </a:srgbClr>
-            </a:solidFill>
-            <a:prstDash val="solid"/>
-          </a:ln>
-        </p:spPr>
-      </p:sp>
       <p:pic>
         <p:nvPicPr>
-          <p:cNvPr id="6" name="Image 0" descr="../assets/intelligaia-logo-full-cream.png">    </p:cNvPr>
+          <p:cNvPr id="2" name="Image 0" descr="../assets/intelligaia-logo-full-ink.png">    </p:cNvPr>
           <p:cNvPicPr>
             <a:picLocks noChangeAspect="1"/>
           </p:cNvPicPr>
@@ -1105,7 +1009,7 @@
       </p:pic>
       <p:sp>
         <p:nvSpPr>
-          <p:cNvPr id="7" name="Text 4"/>
+          <p:cNvPr id="3" name="Text 0"/>
           <p:cNvSpPr/>
           <p:nvPr/>
         </p:nvSpPr>
@@ -1130,7 +1034,7 @@
             <a:r>
               <a:rPr lang="en-US" sz="1200" spc="300" kern="0" dirty="0">
                 <a:solidFill>
-                  <a:srgbClr val="FFD923"/>
+                  <a:srgbClr val="C49A00"/>
                 </a:solidFill>
                 <a:latin typeface="Azeret Mono" pitchFamily="34" charset="0"/>
                 <a:ea typeface="Azeret Mono" pitchFamily="34" charset="-122"/>
@@ -1144,7 +1048,7 @@
       </p:sp>
       <p:sp>
         <p:nvSpPr>
-          <p:cNvPr id="8" name="Text 5"/>
+          <p:cNvPr id="4" name="Text 1"/>
           <p:cNvSpPr/>
           <p:nvPr/>
         </p:nvSpPr>
@@ -1172,7 +1076,7 @@
             <a:r>
               <a:rPr lang="en-US" sz="4600" dirty="0">
                 <a:solidFill>
-                  <a:srgbClr val="FAFAF6"/>
+                  <a:srgbClr val="1A1916"/>
                 </a:solidFill>
                 <a:latin typeface="Trirong" pitchFamily="34" charset="0"/>
                 <a:ea typeface="Trirong" pitchFamily="34" charset="-122"/>
@@ -1189,7 +1093,7 @@
             <a:r>
               <a:rPr lang="en-US" sz="4600" i="1" dirty="0">
                 <a:solidFill>
-                  <a:srgbClr val="FFD923"/>
+                  <a:srgbClr val="C49A00"/>
                 </a:solidFill>
                 <a:latin typeface="Trirong" pitchFamily="34" charset="0"/>
                 <a:ea typeface="Trirong" pitchFamily="34" charset="-122"/>
@@ -1203,7 +1107,7 @@
       </p:sp>
       <p:sp>
         <p:nvSpPr>
-          <p:cNvPr id="9" name="Text 6"/>
+          <p:cNvPr id="5" name="Text 2"/>
           <p:cNvSpPr/>
           <p:nvPr/>
         </p:nvSpPr>
@@ -1231,7 +1135,7 @@
             <a:r>
               <a:rPr lang="en-US" sz="1600" dirty="0">
                 <a:solidFill>
-                  <a:srgbClr val="AEAE9F"/>
+                  <a:srgbClr val="6B6B62"/>
                 </a:solidFill>
                 <a:latin typeface="Raleway" pitchFamily="34" charset="0"/>
                 <a:ea typeface="Raleway" pitchFamily="34" charset="-122"/>
@@ -1245,7 +1149,7 @@
       </p:sp>
       <p:sp>
         <p:nvSpPr>
-          <p:cNvPr id="10" name="Text 7"/>
+          <p:cNvPr id="6" name="Text 3"/>
           <p:cNvSpPr/>
           <p:nvPr/>
         </p:nvSpPr>
@@ -1270,7 +1174,7 @@
             <a:r>
               <a:rPr lang="en-US" sz="900" dirty="0">
                 <a:solidFill>
-                  <a:srgbClr val="AEAE9F"/>
+                  <a:srgbClr val="6B6B62"/>
                 </a:solidFill>
                 <a:latin typeface="Azeret Mono" pitchFamily="34" charset="0"/>
                 <a:ea typeface="Azeret Mono" pitchFamily="34" charset="-122"/>

</xml_diff>